<commit_message>
Add guided Week 3 RideShare professor demo
</commit_message>
<xml_diff>
--- a/lendet/2026-2027/mobile/lectures/ligjerata-03-komponentet-app-router-rideshare-2026.pptx
+++ b/lendet/2026-2027/mobile/lectures/ligjerata-03-komponentet-app-router-rideshare-2026.pptx
@@ -3595,6 +3595,17 @@
             <a:r>
               <a:rPr/>
               <a:t>Ndryshojmë ID në adresë dhe shohim 404.</a:t>
+            </a:r>
+          </a:p>
+          <a:p>
+            <a:pPr lvl="0" indent="0" marL="0">
+              <a:buNone/>
+            </a:pPr>
+            <a:r>
+              <a:rPr>
+                <a:hlinkClick r:id="rId2"/>
+              </a:rPr>
+              <a:t>Hap demonstrimin e Javës 3</a:t>
             </a:r>
           </a:p>
         </p:txBody>

</xml_diff>

<commit_message>
Add guided Week 3 RideShare professor demo (#32)
</commit_message>
<xml_diff>
--- a/lendet/2026-2027/mobile/lectures/ligjerata-03-komponentet-app-router-rideshare-2026.pptx
+++ b/lendet/2026-2027/mobile/lectures/ligjerata-03-komponentet-app-router-rideshare-2026.pptx
@@ -3595,6 +3595,17 @@
             <a:r>
               <a:rPr/>
               <a:t>Ndryshojmë ID në adresë dhe shohim 404.</a:t>
+            </a:r>
+          </a:p>
+          <a:p>
+            <a:pPr lvl="0" indent="0" marL="0">
+              <a:buNone/>
+            </a:pPr>
+            <a:r>
+              <a:rPr>
+                <a:hlinkClick r:id="rId2"/>
+              </a:rPr>
+              <a:t>Hap demonstrimin e Javës 3</a:t>
             </a:r>
           </a:p>
         </p:txBody>

</xml_diff>